<commit_message>
Round-2 formula ablations: peak-normalized Eq.(7) recovers (0.94-1.00), cross-seed/task collapse; course decks/docs updated
</commit_message>
<xml_diff>
--- a/course/RL课程_FINO复现_结果与分析.pptx
+++ b/course/RL课程_FINO复现_结果与分析.pptx
@@ -583,7 +583,7 @@
           <a:lstStyle/>
           <a:p>
             <a:r>
-              <a:t>公式逻辑消融：论文二次型 schedule 按字面实现会崩溃（0.04），官方指数 schedule 最优（1.00）；无噪声和 eta=0.3 都是 0.96，说明噪声不是越强越好；beta 符号方向影响很小（0.94 vs 0.96）。</a:t>
+              <a:t>公式逻辑验证：未缩放 Eq.(7) 崩溃（0.04，seed1 0.12，humanoid 0.00）；把峰值归一化到 0.1 后恢复到 0.94，按方差读法（峰值 0.053）达到 1.00。说明问题在幅度而非形状。K=1/4/10 为 0.90/0.94/0.96，β 影响很小。</a:t>
             </a:r>
           </a:p>
         </p:txBody>
@@ -4807,7 +4807,7 @@
                 <a:ea typeface="Microsoft YaHei"/>
                 <a:cs typeface="Microsoft YaHei"/>
               </a:rPr>
-              <a:t>公式逻辑验证：论文公式 vs 实现（antmaze-large，全预算）</a:t>
+              <a:t>公式逻辑验证：Eq.(7) 的问题在"幅度"而非"形状"</a:t>
             </a:r>
           </a:p>
         </p:txBody>
@@ -4949,8 +4949,8 @@
         </p:nvSpPr>
         <p:spPr>
           <a:xfrm>
-            <a:off x="685800" y="1389888"/>
-            <a:ext cx="5577840" cy="1874519"/>
+            <a:off x="685800" y="1371600"/>
+            <a:ext cx="5669280" cy="2148840"/>
           </a:xfrm>
           <a:prstGeom prst="roundRect">
             <a:avLst>
@@ -4997,8 +4997,8 @@
         </p:nvSpPr>
         <p:spPr>
           <a:xfrm>
-            <a:off x="914400" y="1481328"/>
-            <a:ext cx="5120640" cy="256032"/>
+            <a:off x="914400" y="1463040"/>
+            <a:ext cx="5212080" cy="256032"/>
           </a:xfrm>
           <a:prstGeom prst="rect">
             <a:avLst/>
@@ -5025,7 +5025,7 @@
                 <a:ea typeface="Microsoft YaHei"/>
                 <a:cs typeface="Microsoft YaHei"/>
               </a:rPr>
-              <a:t>A. 噪声 schedule（从零 1M+500k）</a:t>
+              <a:t>A. 噪声 schedule（antmaze-large 全预算）</a:t>
             </a:r>
           </a:p>
         </p:txBody>
@@ -5039,8 +5039,8 @@
           <p:nvPr/>
         </p:nvGraphicFramePr>
         <p:xfrm>
-          <a:off x="914400" y="1773936"/>
-          <a:ext cx="5120639" cy="1280160"/>
+          <a:off x="914400" y="1737360"/>
+          <a:ext cx="5212078" cy="1563624"/>
         </p:xfrm>
         <a:graphic>
           <a:graphicData uri="http://schemas.openxmlformats.org/drawingml/2006/table">
@@ -5049,10 +5049,10 @@
                 <a:tableStyleId>{2D5ABB26-0587-4C30-8999-92F81FD0307C}</a:tableStyleId>
               </a:tblPr>
               <a:tblGrid>
-                <a:gridCol w="2355494"/>
-                <a:gridCol w="921715"/>
-                <a:gridCol w="921715"/>
-                <a:gridCol w="921715"/>
+                <a:gridCol w="2293315"/>
+                <a:gridCol w="833932"/>
+                <a:gridCol w="833932"/>
+                <a:gridCol w="1250899"/>
               </a:tblGrid>
               <a:tr h="329184">
                 <a:tc>
@@ -5066,7 +5066,7 @@
                         </a:lnSpc>
                       </a:pPr>
                       <a:r>
-                        <a:rPr sz="819" b="1">
+                        <a:rPr sz="780" b="1">
                           <a:solidFill>
                             <a:srgbClr val="FFFFFF"/>
                           </a:solidFill>
@@ -5095,7 +5095,7 @@
                         </a:lnSpc>
                       </a:pPr>
                       <a:r>
-                        <a:rPr sz="819" b="1">
+                        <a:rPr sz="780" b="1">
                           <a:solidFill>
                             <a:srgbClr val="FFFFFF"/>
                           </a:solidFill>
@@ -5124,7 +5124,7 @@
                         </a:lnSpc>
                       </a:pPr>
                       <a:r>
-                        <a:rPr sz="819" b="1">
+                        <a:rPr sz="780" b="1">
                           <a:solidFill>
                             <a:srgbClr val="FFFFFF"/>
                           </a:solidFill>
@@ -5153,7 +5153,7 @@
                         </a:lnSpc>
                       </a:pPr>
                       <a:r>
-                        <a:rPr sz="819" b="1">
+                        <a:rPr sz="780" b="1">
                           <a:solidFill>
                             <a:srgbClr val="FFFFFF"/>
                           </a:solidFill>
@@ -5161,7 +5161,7 @@
                           <a:ea typeface="Microsoft YaHei"/>
                           <a:cs typeface="Microsoft YaHei"/>
                         </a:rPr>
-                        <a:t>last-5</a:t>
+                        <a:t>说明</a:t>
                       </a:r>
                     </a:p>
                   </a:txBody>
@@ -5172,7 +5172,7 @@
                   </a:tcPr>
                 </a:tc>
               </a:tr>
-              <a:tr h="237744">
+              <a:tr h="246888">
                 <a:tc>
                   <a:txBody>
                     <a:bodyPr wrap="square"/>
@@ -5184,7 +5184,7 @@
                         </a:lnSpc>
                       </a:pPr>
                       <a:r>
-                        <a:rPr sz="819" b="1">
+                        <a:rPr sz="780" b="1">
                           <a:solidFill>
                             <a:srgbClr val="0F1B2D"/>
                           </a:solidFill>
@@ -5213,7 +5213,7 @@
                         </a:lnSpc>
                       </a:pPr>
                       <a:r>
-                        <a:rPr sz="819" b="0">
+                        <a:rPr sz="780" b="0">
                           <a:solidFill>
                             <a:srgbClr val="1B263B"/>
                           </a:solidFill>
@@ -5242,7 +5242,450 @@
                         </a:lnSpc>
                       </a:pPr>
                       <a:r>
-                        <a:rPr sz="819" b="0">
+                        <a:rPr sz="780" b="0">
+                          <a:solidFill>
+                            <a:srgbClr val="1B263B"/>
+                          </a:solidFill>
+                          <a:latin typeface="Microsoft YaHei"/>
+                          <a:ea typeface="Microsoft YaHei"/>
+                          <a:cs typeface="Microsoft YaHei"/>
+                        </a:rPr>
+                        <a:t>1.00</a:t>
+                      </a:r>
+                    </a:p>
+                  </a:txBody>
+                  <a:tcPr marL="73152" marR="54864" marT="18288" marB="18288" anchor="ctr">
+                    <a:solidFill>
+                      <a:srgbClr val="FFFFFF"/>
+                    </a:solidFill>
+                  </a:tcPr>
+                </a:tc>
+                <a:tc>
+                  <a:txBody>
+                    <a:bodyPr wrap="square"/>
+                    <a:lstStyle/>
+                    <a:p>
+                      <a:pPr algn="l">
+                        <a:lnSpc>
+                          <a:spcPct val="100000"/>
+                        </a:lnSpc>
+                      </a:pPr>
+                      <a:r>
+                        <a:rPr sz="780" b="0">
+                          <a:solidFill>
+                            <a:srgbClr val="1B263B"/>
+                          </a:solidFill>
+                          <a:latin typeface="Microsoft YaHei"/>
+                          <a:ea typeface="Microsoft YaHei"/>
+                          <a:cs typeface="Microsoft YaHei"/>
+                        </a:rPr>
+                        <a:t>主实验基线</a:t>
+                      </a:r>
+                    </a:p>
+                  </a:txBody>
+                  <a:tcPr marL="73152" marR="54864" marT="18288" marB="18288" anchor="ctr">
+                    <a:solidFill>
+                      <a:srgbClr val="FFFFFF"/>
+                    </a:solidFill>
+                  </a:tcPr>
+                </a:tc>
+              </a:tr>
+              <a:tr h="246888">
+                <a:tc>
+                  <a:txBody>
+                    <a:bodyPr wrap="square"/>
+                    <a:lstStyle/>
+                    <a:p>
+                      <a:pPr algn="l">
+                        <a:lnSpc>
+                          <a:spcPct val="100000"/>
+                        </a:lnSpc>
+                      </a:pPr>
+                      <a:r>
+                        <a:rPr sz="780" b="1">
+                          <a:solidFill>
+                            <a:srgbClr val="0F1B2D"/>
+                          </a:solidFill>
+                          <a:latin typeface="Microsoft YaHei"/>
+                          <a:ea typeface="Microsoft YaHei"/>
+                          <a:cs typeface="Microsoft YaHei"/>
+                        </a:rPr>
+                        <a:t>无噪声 η=0</a:t>
+                      </a:r>
+                    </a:p>
+                  </a:txBody>
+                  <a:tcPr marL="73152" marR="54864" marT="18288" marB="18288" anchor="ctr">
+                    <a:solidFill>
+                      <a:srgbClr val="F5F7FB"/>
+                    </a:solidFill>
+                  </a:tcPr>
+                </a:tc>
+                <a:tc>
+                  <a:txBody>
+                    <a:bodyPr wrap="square"/>
+                    <a:lstStyle/>
+                    <a:p>
+                      <a:pPr algn="ctr">
+                        <a:lnSpc>
+                          <a:spcPct val="100000"/>
+                        </a:lnSpc>
+                      </a:pPr>
+                      <a:r>
+                        <a:rPr sz="780" b="0">
+                          <a:solidFill>
+                            <a:srgbClr val="1B263B"/>
+                          </a:solidFill>
+                          <a:latin typeface="Microsoft YaHei"/>
+                          <a:ea typeface="Microsoft YaHei"/>
+                          <a:cs typeface="Microsoft YaHei"/>
+                        </a:rPr>
+                        <a:t>0.96</a:t>
+                      </a:r>
+                    </a:p>
+                  </a:txBody>
+                  <a:tcPr marL="73152" marR="54864" marT="18288" marB="18288" anchor="ctr">
+                    <a:solidFill>
+                      <a:srgbClr val="F5F7FB"/>
+                    </a:solidFill>
+                  </a:tcPr>
+                </a:tc>
+                <a:tc>
+                  <a:txBody>
+                    <a:bodyPr wrap="square"/>
+                    <a:lstStyle/>
+                    <a:p>
+                      <a:pPr algn="ctr">
+                        <a:lnSpc>
+                          <a:spcPct val="100000"/>
+                        </a:lnSpc>
+                      </a:pPr>
+                      <a:r>
+                        <a:rPr sz="780" b="0">
+                          <a:solidFill>
+                            <a:srgbClr val="1B263B"/>
+                          </a:solidFill>
+                          <a:latin typeface="Microsoft YaHei"/>
+                          <a:ea typeface="Microsoft YaHei"/>
+                          <a:cs typeface="Microsoft YaHei"/>
+                        </a:rPr>
+                        <a:t>0.98</a:t>
+                      </a:r>
+                    </a:p>
+                  </a:txBody>
+                  <a:tcPr marL="73152" marR="54864" marT="18288" marB="18288" anchor="ctr">
+                    <a:solidFill>
+                      <a:srgbClr val="F5F7FB"/>
+                    </a:solidFill>
+                  </a:tcPr>
+                </a:tc>
+                <a:tc>
+                  <a:txBody>
+                    <a:bodyPr wrap="square"/>
+                    <a:lstStyle/>
+                    <a:p>
+                      <a:pPr algn="l">
+                        <a:lnSpc>
+                          <a:spcPct val="100000"/>
+                        </a:lnSpc>
+                      </a:pPr>
+                      <a:r>
+                        <a:rPr sz="780" b="0">
+                          <a:solidFill>
+                            <a:srgbClr val="1B263B"/>
+                          </a:solidFill>
+                          <a:latin typeface="Microsoft YaHei"/>
+                          <a:ea typeface="Microsoft YaHei"/>
+                          <a:cs typeface="Microsoft YaHei"/>
+                        </a:rPr>
+                        <a:t>去掉注入</a:t>
+                      </a:r>
+                    </a:p>
+                  </a:txBody>
+                  <a:tcPr marL="73152" marR="54864" marT="18288" marB="18288" anchor="ctr">
+                    <a:solidFill>
+                      <a:srgbClr val="F5F7FB"/>
+                    </a:solidFill>
+                  </a:tcPr>
+                </a:tc>
+              </a:tr>
+              <a:tr h="246888">
+                <a:tc>
+                  <a:txBody>
+                    <a:bodyPr wrap="square"/>
+                    <a:lstStyle/>
+                    <a:p>
+                      <a:pPr algn="l">
+                        <a:lnSpc>
+                          <a:spcPct val="100000"/>
+                        </a:lnSpc>
+                      </a:pPr>
+                      <a:r>
+                        <a:rPr sz="780" b="1">
+                          <a:solidFill>
+                            <a:srgbClr val="0F1B2D"/>
+                          </a:solidFill>
+                          <a:latin typeface="Microsoft YaHei"/>
+                          <a:ea typeface="Microsoft YaHei"/>
+                          <a:cs typeface="Microsoft YaHei"/>
+                        </a:rPr>
+                        <a:t>Eq.(7) 未缩放</a:t>
+                      </a:r>
+                    </a:p>
+                  </a:txBody>
+                  <a:tcPr marL="73152" marR="54864" marT="18288" marB="18288" anchor="ctr">
+                    <a:solidFill>
+                      <a:srgbClr val="FFFFFF"/>
+                    </a:solidFill>
+                  </a:tcPr>
+                </a:tc>
+                <a:tc>
+                  <a:txBody>
+                    <a:bodyPr wrap="square"/>
+                    <a:lstStyle/>
+                    <a:p>
+                      <a:pPr algn="ctr">
+                        <a:lnSpc>
+                          <a:spcPct val="100000"/>
+                        </a:lnSpc>
+                      </a:pPr>
+                      <a:r>
+                        <a:rPr sz="780" b="0">
+                          <a:solidFill>
+                            <a:srgbClr val="1B263B"/>
+                          </a:solidFill>
+                          <a:latin typeface="Microsoft YaHei"/>
+                          <a:ea typeface="Microsoft YaHei"/>
+                          <a:cs typeface="Microsoft YaHei"/>
+                        </a:rPr>
+                        <a:t>0.04</a:t>
+                      </a:r>
+                    </a:p>
+                  </a:txBody>
+                  <a:tcPr marL="73152" marR="54864" marT="18288" marB="18288" anchor="ctr">
+                    <a:solidFill>
+                      <a:srgbClr val="FFFFFF"/>
+                    </a:solidFill>
+                  </a:tcPr>
+                </a:tc>
+                <a:tc>
+                  <a:txBody>
+                    <a:bodyPr wrap="square"/>
+                    <a:lstStyle/>
+                    <a:p>
+                      <a:pPr algn="ctr">
+                        <a:lnSpc>
+                          <a:spcPct val="100000"/>
+                        </a:lnSpc>
+                      </a:pPr>
+                      <a:r>
+                        <a:rPr sz="780" b="0">
+                          <a:solidFill>
+                            <a:srgbClr val="1B263B"/>
+                          </a:solidFill>
+                          <a:latin typeface="Microsoft YaHei"/>
+                          <a:ea typeface="Microsoft YaHei"/>
+                          <a:cs typeface="Microsoft YaHei"/>
+                        </a:rPr>
+                        <a:t>0.62</a:t>
+                      </a:r>
+                    </a:p>
+                  </a:txBody>
+                  <a:tcPr marL="73152" marR="54864" marT="18288" marB="18288" anchor="ctr">
+                    <a:solidFill>
+                      <a:srgbClr val="FFFFFF"/>
+                    </a:solidFill>
+                  </a:tcPr>
+                </a:tc>
+                <a:tc>
+                  <a:txBody>
+                    <a:bodyPr wrap="square"/>
+                    <a:lstStyle/>
+                    <a:p>
+                      <a:pPr algn="l">
+                        <a:lnSpc>
+                          <a:spcPct val="100000"/>
+                        </a:lnSpc>
+                      </a:pPr>
+                      <a:r>
+                        <a:rPr sz="780" b="0">
+                          <a:solidFill>
+                            <a:srgbClr val="1B263B"/>
+                          </a:solidFill>
+                          <a:latin typeface="Microsoft YaHei"/>
+                          <a:ea typeface="Microsoft YaHei"/>
+                          <a:cs typeface="Microsoft YaHei"/>
+                        </a:rPr>
+                        <a:t>峰值 0.229（340×）</a:t>
+                      </a:r>
+                    </a:p>
+                  </a:txBody>
+                  <a:tcPr marL="73152" marR="54864" marT="18288" marB="18288" anchor="ctr">
+                    <a:solidFill>
+                      <a:srgbClr val="FFFFFF"/>
+                    </a:solidFill>
+                  </a:tcPr>
+                </a:tc>
+              </a:tr>
+              <a:tr h="246888">
+                <a:tc>
+                  <a:txBody>
+                    <a:bodyPr wrap="square"/>
+                    <a:lstStyle/>
+                    <a:p>
+                      <a:pPr algn="l">
+                        <a:lnSpc>
+                          <a:spcPct val="100000"/>
+                        </a:lnSpc>
+                      </a:pPr>
+                      <a:r>
+                        <a:rPr sz="780" b="1">
+                          <a:solidFill>
+                            <a:srgbClr val="0F1B2D"/>
+                          </a:solidFill>
+                          <a:latin typeface="Microsoft YaHei"/>
+                          <a:ea typeface="Microsoft YaHei"/>
+                          <a:cs typeface="Microsoft YaHei"/>
+                        </a:rPr>
+                        <a:t>Eq.(7) 峰值匹配</a:t>
+                      </a:r>
+                    </a:p>
+                  </a:txBody>
+                  <a:tcPr marL="73152" marR="54864" marT="18288" marB="18288" anchor="ctr">
+                    <a:solidFill>
+                      <a:srgbClr val="F5F7FB"/>
+                    </a:solidFill>
+                  </a:tcPr>
+                </a:tc>
+                <a:tc>
+                  <a:txBody>
+                    <a:bodyPr wrap="square"/>
+                    <a:lstStyle/>
+                    <a:p>
+                      <a:pPr algn="ctr">
+                        <a:lnSpc>
+                          <a:spcPct val="100000"/>
+                        </a:lnSpc>
+                      </a:pPr>
+                      <a:r>
+                        <a:rPr sz="780" b="0">
+                          <a:solidFill>
+                            <a:srgbClr val="1B263B"/>
+                          </a:solidFill>
+                          <a:latin typeface="Microsoft YaHei"/>
+                          <a:ea typeface="Microsoft YaHei"/>
+                          <a:cs typeface="Microsoft YaHei"/>
+                        </a:rPr>
+                        <a:t>0.94</a:t>
+                      </a:r>
+                    </a:p>
+                  </a:txBody>
+                  <a:tcPr marL="73152" marR="54864" marT="18288" marB="18288" anchor="ctr">
+                    <a:solidFill>
+                      <a:srgbClr val="F5F7FB"/>
+                    </a:solidFill>
+                  </a:tcPr>
+                </a:tc>
+                <a:tc>
+                  <a:txBody>
+                    <a:bodyPr wrap="square"/>
+                    <a:lstStyle/>
+                    <a:p>
+                      <a:pPr algn="ctr">
+                        <a:lnSpc>
+                          <a:spcPct val="100000"/>
+                        </a:lnSpc>
+                      </a:pPr>
+                      <a:r>
+                        <a:rPr sz="780" b="0">
+                          <a:solidFill>
+                            <a:srgbClr val="1B263B"/>
+                          </a:solidFill>
+                          <a:latin typeface="Microsoft YaHei"/>
+                          <a:ea typeface="Microsoft YaHei"/>
+                          <a:cs typeface="Microsoft YaHei"/>
+                        </a:rPr>
+                        <a:t>0.94</a:t>
+                      </a:r>
+                    </a:p>
+                  </a:txBody>
+                  <a:tcPr marL="73152" marR="54864" marT="18288" marB="18288" anchor="ctr">
+                    <a:solidFill>
+                      <a:srgbClr val="F5F7FB"/>
+                    </a:solidFill>
+                  </a:tcPr>
+                </a:tc>
+                <a:tc>
+                  <a:txBody>
+                    <a:bodyPr wrap="square"/>
+                    <a:lstStyle/>
+                    <a:p>
+                      <a:pPr algn="l">
+                        <a:lnSpc>
+                          <a:spcPct val="100000"/>
+                        </a:lnSpc>
+                      </a:pPr>
+                      <a:r>
+                        <a:rPr sz="780" b="0">
+                          <a:solidFill>
+                            <a:srgbClr val="1B263B"/>
+                          </a:solidFill>
+                          <a:latin typeface="Microsoft YaHei"/>
+                          <a:ea typeface="Microsoft YaHei"/>
+                          <a:cs typeface="Microsoft YaHei"/>
+                        </a:rPr>
+                        <a:t>峰值=0.1</a:t>
+                      </a:r>
+                    </a:p>
+                  </a:txBody>
+                  <a:tcPr marL="73152" marR="54864" marT="18288" marB="18288" anchor="ctr">
+                    <a:solidFill>
+                      <a:srgbClr val="F5F7FB"/>
+                    </a:solidFill>
+                  </a:tcPr>
+                </a:tc>
+              </a:tr>
+              <a:tr h="246888">
+                <a:tc>
+                  <a:txBody>
+                    <a:bodyPr wrap="square"/>
+                    <a:lstStyle/>
+                    <a:p>
+                      <a:pPr algn="l">
+                        <a:lnSpc>
+                          <a:spcPct val="100000"/>
+                        </a:lnSpc>
+                      </a:pPr>
+                      <a:r>
+                        <a:rPr sz="780" b="1">
+                          <a:solidFill>
+                            <a:srgbClr val="0F1B2D"/>
+                          </a:solidFill>
+                          <a:latin typeface="Microsoft YaHei"/>
+                          <a:ea typeface="Microsoft YaHei"/>
+                          <a:cs typeface="Microsoft YaHei"/>
+                        </a:rPr>
+                        <a:t>Eq.(7) 方差读法</a:t>
+                      </a:r>
+                    </a:p>
+                  </a:txBody>
+                  <a:tcPr marL="73152" marR="54864" marT="18288" marB="18288" anchor="ctr">
+                    <a:solidFill>
+                      <a:srgbClr val="FFFFFF"/>
+                    </a:solidFill>
+                  </a:tcPr>
+                </a:tc>
+                <a:tc>
+                  <a:txBody>
+                    <a:bodyPr wrap="square"/>
+                    <a:lstStyle/>
+                    <a:p>
+                      <a:pPr algn="ctr">
+                        <a:lnSpc>
+                          <a:spcPct val="100000"/>
+                        </a:lnSpc>
+                      </a:pPr>
+                      <a:r>
+                        <a:rPr sz="780" b="0">
                           <a:solidFill>
                             <a:srgbClr val="1B263B"/>
                           </a:solidFill>
@@ -5271,7 +5714,7 @@
                         </a:lnSpc>
                       </a:pPr>
                       <a:r>
-                        <a:rPr sz="819" b="0">
+                        <a:rPr sz="780" b="0">
                           <a:solidFill>
                             <a:srgbClr val="1B263B"/>
                           </a:solidFill>
@@ -5279,13 +5722,277 @@
                           <a:ea typeface="Microsoft YaHei"/>
                           <a:cs typeface="Microsoft YaHei"/>
                         </a:rPr>
-                        <a:t>0.98</a:t>
+                        <a:t>1.00</a:t>
                       </a:r>
                     </a:p>
                   </a:txBody>
                   <a:tcPr marL="73152" marR="54864" marT="18288" marB="18288" anchor="ctr">
                     <a:solidFill>
                       <a:srgbClr val="FFFFFF"/>
+                    </a:solidFill>
+                  </a:tcPr>
+                </a:tc>
+                <a:tc>
+                  <a:txBody>
+                    <a:bodyPr wrap="square"/>
+                    <a:lstStyle/>
+                    <a:p>
+                      <a:pPr algn="l">
+                        <a:lnSpc>
+                          <a:spcPct val="100000"/>
+                        </a:lnSpc>
+                      </a:pPr>
+                      <a:r>
+                        <a:rPr sz="780" b="0">
+                          <a:solidFill>
+                            <a:srgbClr val="1B263B"/>
+                          </a:solidFill>
+                          <a:latin typeface="Microsoft YaHei"/>
+                          <a:ea typeface="Microsoft YaHei"/>
+                          <a:cs typeface="Microsoft YaHei"/>
+                        </a:rPr>
+                        <a:t>σ=α²（峰值 0.053）</a:t>
+                      </a:r>
+                    </a:p>
+                  </a:txBody>
+                  <a:tcPr marL="73152" marR="54864" marT="18288" marB="18288" anchor="ctr">
+                    <a:solidFill>
+                      <a:srgbClr val="FFFFFF"/>
+                    </a:solidFill>
+                  </a:tcPr>
+                </a:tc>
+              </a:tr>
+            </a:tbl>
+          </a:graphicData>
+        </a:graphic>
+      </p:graphicFrame>
+      <p:sp>
+        <p:nvSpPr>
+          <p:cNvPr id="11" name="Rounded Rectangle 10"/>
+          <p:cNvSpPr/>
+          <p:nvPr/>
+        </p:nvSpPr>
+        <p:spPr>
+          <a:xfrm>
+            <a:off x="6492240" y="1371600"/>
+            <a:ext cx="5010912" cy="2148840"/>
+          </a:xfrm>
+          <a:prstGeom prst="roundRect">
+            <a:avLst>
+              <a:gd name="adj" fmla="val 5000"/>
+            </a:avLst>
+          </a:prstGeom>
+          <a:solidFill>
+            <a:srgbClr val="F5F7FB"/>
+          </a:solidFill>
+          <a:ln w="9525">
+            <a:solidFill>
+              <a:srgbClr val="E2E7EE"/>
+            </a:solidFill>
+          </a:ln>
+          <a:effectLst/>
+        </p:spPr>
+        <p:style>
+          <a:lnRef idx="1">
+            <a:schemeClr val="accent1"/>
+          </a:lnRef>
+          <a:fillRef idx="3">
+            <a:schemeClr val="accent1"/>
+          </a:fillRef>
+          <a:effectRef idx="2">
+            <a:schemeClr val="accent1"/>
+          </a:effectRef>
+          <a:fontRef idx="minor">
+            <a:schemeClr val="lt1"/>
+          </a:fontRef>
+        </p:style>
+        <p:txBody>
+          <a:bodyPr rtlCol="0" anchor="ctr"/>
+          <a:lstStyle/>
+          <a:p>
+            <a:pPr algn="ctr"/>
+          </a:p>
+        </p:txBody>
+      </p:sp>
+      <p:sp>
+        <p:nvSpPr>
+          <p:cNvPr id="12" name="TextBox 11"/>
+          <p:cNvSpPr txBox="1"/>
+          <p:nvPr/>
+        </p:nvSpPr>
+        <p:spPr>
+          <a:xfrm>
+            <a:off x="6720840" y="1463040"/>
+            <a:ext cx="4572000" cy="256032"/>
+          </a:xfrm>
+          <a:prstGeom prst="rect">
+            <a:avLst/>
+          </a:prstGeom>
+          <a:noFill/>
+        </p:spPr>
+        <p:txBody>
+          <a:bodyPr wrap="square" lIns="0" rIns="0" tIns="0" bIns="0" anchor="t">
+            <a:spAutoFit/>
+          </a:bodyPr>
+          <a:lstStyle/>
+          <a:p>
+            <a:pPr algn="l">
+              <a:lnSpc>
+                <a:spcPct val="118000"/>
+              </a:lnSpc>
+            </a:pPr>
+            <a:r>
+              <a:rPr sz="1080" b="1">
+                <a:solidFill>
+                  <a:srgbClr val="0F1B2D"/>
+                </a:solidFill>
+                <a:latin typeface="Microsoft YaHei"/>
+                <a:ea typeface="Microsoft YaHei"/>
+                <a:cs typeface="Microsoft YaHei"/>
+              </a:rPr>
+              <a:t>B. Q-guided K 与稳健性</a:t>
+            </a:r>
+          </a:p>
+        </p:txBody>
+      </p:sp>
+      <p:graphicFrame>
+        <p:nvGraphicFramePr>
+          <p:cNvPr id="13" name="Table 12"/>
+          <p:cNvGraphicFramePr>
+            <a:graphicFrameLocks noGrp="1"/>
+          </p:cNvGraphicFramePr>
+          <p:nvPr/>
+        </p:nvGraphicFramePr>
+        <p:xfrm>
+          <a:off x="6720840" y="1737360"/>
+          <a:ext cx="4572000" cy="1042416"/>
+        </p:xfrm>
+        <a:graphic>
+          <a:graphicData uri="http://schemas.openxmlformats.org/drawingml/2006/table">
+            <a:tbl>
+              <a:tblPr firstRow="1" bandRow="1">
+                <a:tableStyleId>{2D5ABB26-0587-4C30-8999-92F81FD0307C}</a:tableStyleId>
+              </a:tblPr>
+              <a:tblGrid>
+                <a:gridCol w="1554480"/>
+                <a:gridCol w="1005840"/>
+                <a:gridCol w="1005840"/>
+                <a:gridCol w="1005840"/>
+              </a:tblGrid>
+              <a:tr h="329184">
+                <a:tc>
+                  <a:txBody>
+                    <a:bodyPr wrap="square"/>
+                    <a:lstStyle/>
+                    <a:p>
+                      <a:pPr algn="l">
+                        <a:lnSpc>
+                          <a:spcPct val="100000"/>
+                        </a:lnSpc>
+                      </a:pPr>
+                      <a:r>
+                        <a:rPr sz="780" b="1">
+                          <a:solidFill>
+                            <a:srgbClr val="FFFFFF"/>
+                          </a:solidFill>
+                          <a:latin typeface="Microsoft YaHei"/>
+                          <a:ea typeface="Microsoft YaHei"/>
+                          <a:cs typeface="Microsoft YaHei"/>
+                        </a:rPr>
+                        <a:t>变体</a:t>
+                      </a:r>
+                    </a:p>
+                  </a:txBody>
+                  <a:tcPr marL="73152" marR="54864" marT="18288" marB="18288" anchor="ctr">
+                    <a:solidFill>
+                      <a:srgbClr val="0F1B2D"/>
+                    </a:solidFill>
+                  </a:tcPr>
+                </a:tc>
+                <a:tc>
+                  <a:txBody>
+                    <a:bodyPr wrap="square"/>
+                    <a:lstStyle/>
+                    <a:p>
+                      <a:pPr algn="ctr">
+                        <a:lnSpc>
+                          <a:spcPct val="100000"/>
+                        </a:lnSpc>
+                      </a:pPr>
+                      <a:r>
+                        <a:rPr sz="780" b="1">
+                          <a:solidFill>
+                            <a:srgbClr val="FFFFFF"/>
+                          </a:solidFill>
+                          <a:latin typeface="Microsoft YaHei"/>
+                          <a:ea typeface="Microsoft YaHei"/>
+                          <a:cs typeface="Microsoft YaHei"/>
+                        </a:rPr>
+                        <a:t>最终</a:t>
+                      </a:r>
+                    </a:p>
+                  </a:txBody>
+                  <a:tcPr marL="73152" marR="54864" marT="18288" marB="18288" anchor="ctr">
+                    <a:solidFill>
+                      <a:srgbClr val="0F1B2D"/>
+                    </a:solidFill>
+                  </a:tcPr>
+                </a:tc>
+                <a:tc>
+                  <a:txBody>
+                    <a:bodyPr wrap="square"/>
+                    <a:lstStyle/>
+                    <a:p>
+                      <a:pPr algn="ctr">
+                        <a:lnSpc>
+                          <a:spcPct val="100000"/>
+                        </a:lnSpc>
+                      </a:pPr>
+                      <a:r>
+                        <a:rPr sz="780" b="1">
+                          <a:solidFill>
+                            <a:srgbClr val="FFFFFF"/>
+                          </a:solidFill>
+                          <a:latin typeface="Microsoft YaHei"/>
+                          <a:ea typeface="Microsoft YaHei"/>
+                          <a:cs typeface="Microsoft YaHei"/>
+                        </a:rPr>
+                        <a:t>峰值</a:t>
+                      </a:r>
+                    </a:p>
+                  </a:txBody>
+                  <a:tcPr marL="73152" marR="54864" marT="18288" marB="18288" anchor="ctr">
+                    <a:solidFill>
+                      <a:srgbClr val="0F1B2D"/>
+                    </a:solidFill>
+                  </a:tcPr>
+                </a:tc>
+                <a:tc>
+                  <a:txBody>
+                    <a:bodyPr wrap="square"/>
+                    <a:lstStyle/>
+                    <a:p>
+                      <a:pPr algn="ctr">
+                        <a:lnSpc>
+                          <a:spcPct val="100000"/>
+                        </a:lnSpc>
+                      </a:pPr>
+                      <a:r>
+                        <a:rPr sz="780" b="1">
+                          <a:solidFill>
+                            <a:srgbClr val="FFFFFF"/>
+                          </a:solidFill>
+                          <a:latin typeface="Microsoft YaHei"/>
+                          <a:ea typeface="Microsoft YaHei"/>
+                          <a:cs typeface="Microsoft YaHei"/>
+                        </a:rPr>
+                        <a:t>备注</a:t>
+                      </a:r>
+                    </a:p>
+                  </a:txBody>
+                  <a:tcPr marL="73152" marR="54864" marT="18288" marB="18288" anchor="ctr">
+                    <a:solidFill>
+                      <a:srgbClr val="0F1B2D"/>
                     </a:solidFill>
                   </a:tcPr>
                 </a:tc>
@@ -5302,7 +6009,7 @@
                         </a:lnSpc>
                       </a:pPr>
                       <a:r>
-                        <a:rPr sz="819" b="1">
+                        <a:rPr sz="780" b="1">
                           <a:solidFill>
                             <a:srgbClr val="0F1B2D"/>
                           </a:solidFill>
@@ -5310,125 +6017,7 @@
                           <a:ea typeface="Microsoft YaHei"/>
                           <a:cs typeface="Microsoft YaHei"/>
                         </a:rPr>
-                        <a:t>无噪声 η=0</a:t>
-                      </a:r>
-                    </a:p>
-                  </a:txBody>
-                  <a:tcPr marL="73152" marR="54864" marT="18288" marB="18288" anchor="ctr">
-                    <a:solidFill>
-                      <a:srgbClr val="F5F7FB"/>
-                    </a:solidFill>
-                  </a:tcPr>
-                </a:tc>
-                <a:tc>
-                  <a:txBody>
-                    <a:bodyPr wrap="square"/>
-                    <a:lstStyle/>
-                    <a:p>
-                      <a:pPr algn="ctr">
-                        <a:lnSpc>
-                          <a:spcPct val="100000"/>
-                        </a:lnSpc>
-                      </a:pPr>
-                      <a:r>
-                        <a:rPr sz="819" b="0">
-                          <a:solidFill>
-                            <a:srgbClr val="1B263B"/>
-                          </a:solidFill>
-                          <a:latin typeface="Microsoft YaHei"/>
-                          <a:ea typeface="Microsoft YaHei"/>
-                          <a:cs typeface="Microsoft YaHei"/>
-                        </a:rPr>
-                        <a:t>0.96</a:t>
-                      </a:r>
-                    </a:p>
-                  </a:txBody>
-                  <a:tcPr marL="73152" marR="54864" marT="18288" marB="18288" anchor="ctr">
-                    <a:solidFill>
-                      <a:srgbClr val="F5F7FB"/>
-                    </a:solidFill>
-                  </a:tcPr>
-                </a:tc>
-                <a:tc>
-                  <a:txBody>
-                    <a:bodyPr wrap="square"/>
-                    <a:lstStyle/>
-                    <a:p>
-                      <a:pPr algn="ctr">
-                        <a:lnSpc>
-                          <a:spcPct val="100000"/>
-                        </a:lnSpc>
-                      </a:pPr>
-                      <a:r>
-                        <a:rPr sz="819" b="0">
-                          <a:solidFill>
-                            <a:srgbClr val="1B263B"/>
-                          </a:solidFill>
-                          <a:latin typeface="Microsoft YaHei"/>
-                          <a:ea typeface="Microsoft YaHei"/>
-                          <a:cs typeface="Microsoft YaHei"/>
-                        </a:rPr>
-                        <a:t>0.98</a:t>
-                      </a:r>
-                    </a:p>
-                  </a:txBody>
-                  <a:tcPr marL="73152" marR="54864" marT="18288" marB="18288" anchor="ctr">
-                    <a:solidFill>
-                      <a:srgbClr val="F5F7FB"/>
-                    </a:solidFill>
-                  </a:tcPr>
-                </a:tc>
-                <a:tc>
-                  <a:txBody>
-                    <a:bodyPr wrap="square"/>
-                    <a:lstStyle/>
-                    <a:p>
-                      <a:pPr algn="ctr">
-                        <a:lnSpc>
-                          <a:spcPct val="100000"/>
-                        </a:lnSpc>
-                      </a:pPr>
-                      <a:r>
-                        <a:rPr sz="819" b="0">
-                          <a:solidFill>
-                            <a:srgbClr val="1B263B"/>
-                          </a:solidFill>
-                          <a:latin typeface="Microsoft YaHei"/>
-                          <a:ea typeface="Microsoft YaHei"/>
-                          <a:cs typeface="Microsoft YaHei"/>
-                        </a:rPr>
-                        <a:t>0.88</a:t>
-                      </a:r>
-                    </a:p>
-                  </a:txBody>
-                  <a:tcPr marL="73152" marR="54864" marT="18288" marB="18288" anchor="ctr">
-                    <a:solidFill>
-                      <a:srgbClr val="F5F7FB"/>
-                    </a:solidFill>
-                  </a:tcPr>
-                </a:tc>
-              </a:tr>
-              <a:tr h="237744">
-                <a:tc>
-                  <a:txBody>
-                    <a:bodyPr wrap="square"/>
-                    <a:lstStyle/>
-                    <a:p>
-                      <a:pPr algn="l">
-                        <a:lnSpc>
-                          <a:spcPct val="100000"/>
-                        </a:lnSpc>
-                      </a:pPr>
-                      <a:r>
-                        <a:rPr sz="819" b="1">
-                          <a:solidFill>
-                            <a:srgbClr val="0F1B2D"/>
-                          </a:solidFill>
-                          <a:latin typeface="Microsoft YaHei"/>
-                          <a:ea typeface="Microsoft YaHei"/>
-                          <a:cs typeface="Microsoft YaHei"/>
-                        </a:rPr>
-                        <a:t>指数 η=0.3</a:t>
+                        <a:t>K=1</a:t>
                       </a:r>
                     </a:p>
                   </a:txBody>
@@ -5449,7 +6038,36 @@
                         </a:lnSpc>
                       </a:pPr>
                       <a:r>
-                        <a:rPr sz="819" b="0">
+                        <a:rPr sz="780" b="0">
+                          <a:solidFill>
+                            <a:srgbClr val="1B263B"/>
+                          </a:solidFill>
+                          <a:latin typeface="Microsoft YaHei"/>
+                          <a:ea typeface="Microsoft YaHei"/>
+                          <a:cs typeface="Microsoft YaHei"/>
+                        </a:rPr>
+                        <a:t>0.90</a:t>
+                      </a:r>
+                    </a:p>
+                  </a:txBody>
+                  <a:tcPr marL="73152" marR="54864" marT="18288" marB="18288" anchor="ctr">
+                    <a:solidFill>
+                      <a:srgbClr val="FFFFFF"/>
+                    </a:solidFill>
+                  </a:tcPr>
+                </a:tc>
+                <a:tc>
+                  <a:txBody>
+                    <a:bodyPr wrap="square"/>
+                    <a:lstStyle/>
+                    <a:p>
+                      <a:pPr algn="ctr">
+                        <a:lnSpc>
+                          <a:spcPct val="100000"/>
+                        </a:lnSpc>
+                      </a:pPr>
+                      <a:r>
+                        <a:rPr sz="780" b="0">
                           <a:solidFill>
                             <a:srgbClr val="1B263B"/>
                           </a:solidFill>
@@ -5478,7 +6096,185 @@
                         </a:lnSpc>
                       </a:pPr>
                       <a:r>
-                        <a:rPr sz="819" b="0">
+                        <a:rPr sz="780" b="0">
+                          <a:solidFill>
+                            <a:srgbClr val="1B263B"/>
+                          </a:solidFill>
+                          <a:latin typeface="Microsoft YaHei"/>
+                          <a:ea typeface="Microsoft YaHei"/>
+                          <a:cs typeface="Microsoft YaHei"/>
+                        </a:rPr>
+                        <a:t>退化</a:t>
+                      </a:r>
+                    </a:p>
+                  </a:txBody>
+                  <a:tcPr marL="73152" marR="54864" marT="18288" marB="18288" anchor="ctr">
+                    <a:solidFill>
+                      <a:srgbClr val="FFFFFF"/>
+                    </a:solidFill>
+                  </a:tcPr>
+                </a:tc>
+              </a:tr>
+              <a:tr h="237744">
+                <a:tc>
+                  <a:txBody>
+                    <a:bodyPr wrap="square"/>
+                    <a:lstStyle/>
+                    <a:p>
+                      <a:pPr algn="l">
+                        <a:lnSpc>
+                          <a:spcPct val="100000"/>
+                        </a:lnSpc>
+                      </a:pPr>
+                      <a:r>
+                        <a:rPr sz="780" b="1">
+                          <a:solidFill>
+                            <a:srgbClr val="0F1B2D"/>
+                          </a:solidFill>
+                          <a:latin typeface="Microsoft YaHei"/>
+                          <a:ea typeface="Microsoft YaHei"/>
+                          <a:cs typeface="Microsoft YaHei"/>
+                        </a:rPr>
+                        <a:t>K=4</a:t>
+                      </a:r>
+                    </a:p>
+                  </a:txBody>
+                  <a:tcPr marL="73152" marR="54864" marT="18288" marB="18288" anchor="ctr">
+                    <a:solidFill>
+                      <a:srgbClr val="F5F7FB"/>
+                    </a:solidFill>
+                  </a:tcPr>
+                </a:tc>
+                <a:tc>
+                  <a:txBody>
+                    <a:bodyPr wrap="square"/>
+                    <a:lstStyle/>
+                    <a:p>
+                      <a:pPr algn="ctr">
+                        <a:lnSpc>
+                          <a:spcPct val="100000"/>
+                        </a:lnSpc>
+                      </a:pPr>
+                      <a:r>
+                        <a:rPr sz="780" b="0">
+                          <a:solidFill>
+                            <a:srgbClr val="1B263B"/>
+                          </a:solidFill>
+                          <a:latin typeface="Microsoft YaHei"/>
+                          <a:ea typeface="Microsoft YaHei"/>
+                          <a:cs typeface="Microsoft YaHei"/>
+                        </a:rPr>
+                        <a:t>0.94</a:t>
+                      </a:r>
+                    </a:p>
+                  </a:txBody>
+                  <a:tcPr marL="73152" marR="54864" marT="18288" marB="18288" anchor="ctr">
+                    <a:solidFill>
+                      <a:srgbClr val="F5F7FB"/>
+                    </a:solidFill>
+                  </a:tcPr>
+                </a:tc>
+                <a:tc>
+                  <a:txBody>
+                    <a:bodyPr wrap="square"/>
+                    <a:lstStyle/>
+                    <a:p>
+                      <a:pPr algn="ctr">
+                        <a:lnSpc>
+                          <a:spcPct val="100000"/>
+                        </a:lnSpc>
+                      </a:pPr>
+                      <a:r>
+                        <a:rPr sz="780" b="0">
+                          <a:solidFill>
+                            <a:srgbClr val="1B263B"/>
+                          </a:solidFill>
+                          <a:latin typeface="Microsoft YaHei"/>
+                          <a:ea typeface="Microsoft YaHei"/>
+                          <a:cs typeface="Microsoft YaHei"/>
+                        </a:rPr>
+                        <a:t>1.00</a:t>
+                      </a:r>
+                    </a:p>
+                  </a:txBody>
+                  <a:tcPr marL="73152" marR="54864" marT="18288" marB="18288" anchor="ctr">
+                    <a:solidFill>
+                      <a:srgbClr val="F5F7FB"/>
+                    </a:solidFill>
+                  </a:tcPr>
+                </a:tc>
+                <a:tc>
+                  <a:txBody>
+                    <a:bodyPr wrap="square"/>
+                    <a:lstStyle/>
+                    <a:p>
+                      <a:pPr algn="ctr">
+                        <a:lnSpc>
+                          <a:spcPct val="100000"/>
+                        </a:lnSpc>
+                      </a:pPr>
+                      <a:r>
+                        <a:rPr sz="780" b="0">
+                          <a:solidFill>
+                            <a:srgbClr val="1B263B"/>
+                          </a:solidFill>
+                          <a:latin typeface="Microsoft YaHei"/>
+                          <a:ea typeface="Microsoft YaHei"/>
+                          <a:cs typeface="Microsoft YaHei"/>
+                        </a:rPr>
+                        <a:t>官方</a:t>
+                      </a:r>
+                    </a:p>
+                  </a:txBody>
+                  <a:tcPr marL="73152" marR="54864" marT="18288" marB="18288" anchor="ctr">
+                    <a:solidFill>
+                      <a:srgbClr val="F5F7FB"/>
+                    </a:solidFill>
+                  </a:tcPr>
+                </a:tc>
+              </a:tr>
+              <a:tr h="237744">
+                <a:tc>
+                  <a:txBody>
+                    <a:bodyPr wrap="square"/>
+                    <a:lstStyle/>
+                    <a:p>
+                      <a:pPr algn="l">
+                        <a:lnSpc>
+                          <a:spcPct val="100000"/>
+                        </a:lnSpc>
+                      </a:pPr>
+                      <a:r>
+                        <a:rPr sz="780" b="1">
+                          <a:solidFill>
+                            <a:srgbClr val="0F1B2D"/>
+                          </a:solidFill>
+                          <a:latin typeface="Microsoft YaHei"/>
+                          <a:ea typeface="Microsoft YaHei"/>
+                          <a:cs typeface="Microsoft YaHei"/>
+                        </a:rPr>
+                        <a:t>K=10</a:t>
+                      </a:r>
+                    </a:p>
+                  </a:txBody>
+                  <a:tcPr marL="73152" marR="54864" marT="18288" marB="18288" anchor="ctr">
+                    <a:solidFill>
+                      <a:srgbClr val="FFFFFF"/>
+                    </a:solidFill>
+                  </a:tcPr>
+                </a:tc>
+                <a:tc>
+                  <a:txBody>
+                    <a:bodyPr wrap="square"/>
+                    <a:lstStyle/>
+                    <a:p>
+                      <a:pPr algn="ctr">
+                        <a:lnSpc>
+                          <a:spcPct val="100000"/>
+                        </a:lnSpc>
+                      </a:pPr>
+                      <a:r>
+                        <a:rPr sz="780" b="0">
                           <a:solidFill>
                             <a:srgbClr val="1B263B"/>
                           </a:solidFill>
@@ -5507,449 +6303,7 @@
                         </a:lnSpc>
                       </a:pPr>
                       <a:r>
-                        <a:rPr sz="819" b="0">
-                          <a:solidFill>
-                            <a:srgbClr val="1B263B"/>
-                          </a:solidFill>
-                          <a:latin typeface="Microsoft YaHei"/>
-                          <a:ea typeface="Microsoft YaHei"/>
-                          <a:cs typeface="Microsoft YaHei"/>
-                        </a:rPr>
-                        <a:t>0.75</a:t>
-                      </a:r>
-                    </a:p>
-                  </a:txBody>
-                  <a:tcPr marL="73152" marR="54864" marT="18288" marB="18288" anchor="ctr">
-                    <a:solidFill>
-                      <a:srgbClr val="FFFFFF"/>
-                    </a:solidFill>
-                  </a:tcPr>
-                </a:tc>
-              </a:tr>
-              <a:tr h="237744">
-                <a:tc>
-                  <a:txBody>
-                    <a:bodyPr wrap="square"/>
-                    <a:lstStyle/>
-                    <a:p>
-                      <a:pPr algn="l">
-                        <a:lnSpc>
-                          <a:spcPct val="100000"/>
-                        </a:lnSpc>
-                      </a:pPr>
-                      <a:r>
-                        <a:rPr sz="819" b="1">
-                          <a:solidFill>
-                            <a:srgbClr val="0F1B2D"/>
-                          </a:solidFill>
-                          <a:latin typeface="Microsoft YaHei"/>
-                          <a:ea typeface="Microsoft YaHei"/>
-                          <a:cs typeface="Microsoft YaHei"/>
-                        </a:rPr>
-                        <a:t>论文二次型 Eq.(7)</a:t>
-                      </a:r>
-                    </a:p>
-                  </a:txBody>
-                  <a:tcPr marL="73152" marR="54864" marT="18288" marB="18288" anchor="ctr">
-                    <a:solidFill>
-                      <a:srgbClr val="F5F7FB"/>
-                    </a:solidFill>
-                  </a:tcPr>
-                </a:tc>
-                <a:tc>
-                  <a:txBody>
-                    <a:bodyPr wrap="square"/>
-                    <a:lstStyle/>
-                    <a:p>
-                      <a:pPr algn="ctr">
-                        <a:lnSpc>
-                          <a:spcPct val="100000"/>
-                        </a:lnSpc>
-                      </a:pPr>
-                      <a:r>
-                        <a:rPr sz="819" b="0">
-                          <a:solidFill>
-                            <a:srgbClr val="1B263B"/>
-                          </a:solidFill>
-                          <a:latin typeface="Microsoft YaHei"/>
-                          <a:ea typeface="Microsoft YaHei"/>
-                          <a:cs typeface="Microsoft YaHei"/>
-                        </a:rPr>
-                        <a:t>0.04</a:t>
-                      </a:r>
-                    </a:p>
-                  </a:txBody>
-                  <a:tcPr marL="73152" marR="54864" marT="18288" marB="18288" anchor="ctr">
-                    <a:solidFill>
-                      <a:srgbClr val="F5F7FB"/>
-                    </a:solidFill>
-                  </a:tcPr>
-                </a:tc>
-                <a:tc>
-                  <a:txBody>
-                    <a:bodyPr wrap="square"/>
-                    <a:lstStyle/>
-                    <a:p>
-                      <a:pPr algn="ctr">
-                        <a:lnSpc>
-                          <a:spcPct val="100000"/>
-                        </a:lnSpc>
-                      </a:pPr>
-                      <a:r>
-                        <a:rPr sz="819" b="0">
-                          <a:solidFill>
-                            <a:srgbClr val="1B263B"/>
-                          </a:solidFill>
-                          <a:latin typeface="Microsoft YaHei"/>
-                          <a:ea typeface="Microsoft YaHei"/>
-                          <a:cs typeface="Microsoft YaHei"/>
-                        </a:rPr>
-                        <a:t>0.62</a:t>
-                      </a:r>
-                    </a:p>
-                  </a:txBody>
-                  <a:tcPr marL="73152" marR="54864" marT="18288" marB="18288" anchor="ctr">
-                    <a:solidFill>
-                      <a:srgbClr val="F5F7FB"/>
-                    </a:solidFill>
-                  </a:tcPr>
-                </a:tc>
-                <a:tc>
-                  <a:txBody>
-                    <a:bodyPr wrap="square"/>
-                    <a:lstStyle/>
-                    <a:p>
-                      <a:pPr algn="ctr">
-                        <a:lnSpc>
-                          <a:spcPct val="100000"/>
-                        </a:lnSpc>
-                      </a:pPr>
-                      <a:r>
-                        <a:rPr sz="819" b="0">
-                          <a:solidFill>
-                            <a:srgbClr val="1B263B"/>
-                          </a:solidFill>
-                          <a:latin typeface="Microsoft YaHei"/>
-                          <a:ea typeface="Microsoft YaHei"/>
-                          <a:cs typeface="Microsoft YaHei"/>
-                        </a:rPr>
-                        <a:t>0.01</a:t>
-                      </a:r>
-                    </a:p>
-                  </a:txBody>
-                  <a:tcPr marL="73152" marR="54864" marT="18288" marB="18288" anchor="ctr">
-                    <a:solidFill>
-                      <a:srgbClr val="F5F7FB"/>
-                    </a:solidFill>
-                  </a:tcPr>
-                </a:tc>
-              </a:tr>
-            </a:tbl>
-          </a:graphicData>
-        </a:graphic>
-      </p:graphicFrame>
-      <p:sp>
-        <p:nvSpPr>
-          <p:cNvPr id="11" name="Rounded Rectangle 10"/>
-          <p:cNvSpPr/>
-          <p:nvPr/>
-        </p:nvSpPr>
-        <p:spPr>
-          <a:xfrm>
-            <a:off x="6355080" y="1389888"/>
-            <a:ext cx="5148072" cy="1874519"/>
-          </a:xfrm>
-          <a:prstGeom prst="roundRect">
-            <a:avLst>
-              <a:gd name="adj" fmla="val 5000"/>
-            </a:avLst>
-          </a:prstGeom>
-          <a:solidFill>
-            <a:srgbClr val="F5F7FB"/>
-          </a:solidFill>
-          <a:ln w="9525">
-            <a:solidFill>
-              <a:srgbClr val="E2E7EE"/>
-            </a:solidFill>
-          </a:ln>
-          <a:effectLst/>
-        </p:spPr>
-        <p:style>
-          <a:lnRef idx="1">
-            <a:schemeClr val="accent1"/>
-          </a:lnRef>
-          <a:fillRef idx="3">
-            <a:schemeClr val="accent1"/>
-          </a:fillRef>
-          <a:effectRef idx="2">
-            <a:schemeClr val="accent1"/>
-          </a:effectRef>
-          <a:fontRef idx="minor">
-            <a:schemeClr val="lt1"/>
-          </a:fontRef>
-        </p:style>
-        <p:txBody>
-          <a:bodyPr rtlCol="0" anchor="ctr"/>
-          <a:lstStyle/>
-          <a:p>
-            <a:pPr algn="ctr"/>
-          </a:p>
-        </p:txBody>
-      </p:sp>
-      <p:sp>
-        <p:nvSpPr>
-          <p:cNvPr id="12" name="TextBox 11"/>
-          <p:cNvSpPr txBox="1"/>
-          <p:nvPr/>
-        </p:nvSpPr>
-        <p:spPr>
-          <a:xfrm>
-            <a:off x="6583680" y="1481328"/>
-            <a:ext cx="4663440" cy="256032"/>
-          </a:xfrm>
-          <a:prstGeom prst="rect">
-            <a:avLst/>
-          </a:prstGeom>
-          <a:noFill/>
-        </p:spPr>
-        <p:txBody>
-          <a:bodyPr wrap="square" lIns="0" rIns="0" tIns="0" bIns="0" anchor="t">
-            <a:spAutoFit/>
-          </a:bodyPr>
-          <a:lstStyle/>
-          <a:p>
-            <a:pPr algn="l">
-              <a:lnSpc>
-                <a:spcPct val="118000"/>
-              </a:lnSpc>
-            </a:pPr>
-            <a:r>
-              <a:rPr sz="1080" b="1">
-                <a:solidFill>
-                  <a:srgbClr val="0F1B2D"/>
-                </a:solidFill>
-                <a:latin typeface="Microsoft YaHei"/>
-                <a:ea typeface="Microsoft YaHei"/>
-                <a:cs typeface="Microsoft YaHei"/>
-              </a:rPr>
-              <a:t>B. β 更新（1M ckpt 起在线 500k）</a:t>
-            </a:r>
-          </a:p>
-        </p:txBody>
-      </p:sp>
-      <p:graphicFrame>
-        <p:nvGraphicFramePr>
-          <p:cNvPr id="13" name="Table 12"/>
-          <p:cNvGraphicFramePr>
-            <a:graphicFrameLocks noGrp="1"/>
-          </p:cNvGraphicFramePr>
-          <p:nvPr/>
-        </p:nvGraphicFramePr>
-        <p:xfrm>
-          <a:off x="6583680" y="1773936"/>
-          <a:ext cx="4663439" cy="1097280"/>
-        </p:xfrm>
-        <a:graphic>
-          <a:graphicData uri="http://schemas.openxmlformats.org/drawingml/2006/table">
-            <a:tbl>
-              <a:tblPr firstRow="1" bandRow="1">
-                <a:tableStyleId>{2D5ABB26-0587-4C30-8999-92F81FD0307C}</a:tableStyleId>
-              </a:tblPr>
-              <a:tblGrid>
-                <a:gridCol w="2051913"/>
-                <a:gridCol w="839419"/>
-                <a:gridCol w="839419"/>
-                <a:gridCol w="932688"/>
-              </a:tblGrid>
-              <a:tr h="329184">
-                <a:tc>
-                  <a:txBody>
-                    <a:bodyPr wrap="square"/>
-                    <a:lstStyle/>
-                    <a:p>
-                      <a:pPr algn="l">
-                        <a:lnSpc>
-                          <a:spcPct val="100000"/>
-                        </a:lnSpc>
-                      </a:pPr>
-                      <a:r>
-                        <a:rPr sz="819" b="1">
-                          <a:solidFill>
-                            <a:srgbClr val="FFFFFF"/>
-                          </a:solidFill>
-                          <a:latin typeface="Microsoft YaHei"/>
-                          <a:ea typeface="Microsoft YaHei"/>
-                          <a:cs typeface="Microsoft YaHei"/>
-                        </a:rPr>
-                        <a:t>变体</a:t>
-                      </a:r>
-                    </a:p>
-                  </a:txBody>
-                  <a:tcPr marL="73152" marR="54864" marT="18288" marB="18288" anchor="ctr">
-                    <a:solidFill>
-                      <a:srgbClr val="0F1B2D"/>
-                    </a:solidFill>
-                  </a:tcPr>
-                </a:tc>
-                <a:tc>
-                  <a:txBody>
-                    <a:bodyPr wrap="square"/>
-                    <a:lstStyle/>
-                    <a:p>
-                      <a:pPr algn="ctr">
-                        <a:lnSpc>
-                          <a:spcPct val="100000"/>
-                        </a:lnSpc>
-                      </a:pPr>
-                      <a:r>
-                        <a:rPr sz="819" b="1">
-                          <a:solidFill>
-                            <a:srgbClr val="FFFFFF"/>
-                          </a:solidFill>
-                          <a:latin typeface="Microsoft YaHei"/>
-                          <a:ea typeface="Microsoft YaHei"/>
-                          <a:cs typeface="Microsoft YaHei"/>
-                        </a:rPr>
-                        <a:t>最终</a:t>
-                      </a:r>
-                    </a:p>
-                  </a:txBody>
-                  <a:tcPr marL="73152" marR="54864" marT="18288" marB="18288" anchor="ctr">
-                    <a:solidFill>
-                      <a:srgbClr val="0F1B2D"/>
-                    </a:solidFill>
-                  </a:tcPr>
-                </a:tc>
-                <a:tc>
-                  <a:txBody>
-                    <a:bodyPr wrap="square"/>
-                    <a:lstStyle/>
-                    <a:p>
-                      <a:pPr algn="ctr">
-                        <a:lnSpc>
-                          <a:spcPct val="100000"/>
-                        </a:lnSpc>
-                      </a:pPr>
-                      <a:r>
-                        <a:rPr sz="819" b="1">
-                          <a:solidFill>
-                            <a:srgbClr val="FFFFFF"/>
-                          </a:solidFill>
-                          <a:latin typeface="Microsoft YaHei"/>
-                          <a:ea typeface="Microsoft YaHei"/>
-                          <a:cs typeface="Microsoft YaHei"/>
-                        </a:rPr>
-                        <a:t>峰值</a:t>
-                      </a:r>
-                    </a:p>
-                  </a:txBody>
-                  <a:tcPr marL="73152" marR="54864" marT="18288" marB="18288" anchor="ctr">
-                    <a:solidFill>
-                      <a:srgbClr val="0F1B2D"/>
-                    </a:solidFill>
-                  </a:tcPr>
-                </a:tc>
-                <a:tc>
-                  <a:txBody>
-                    <a:bodyPr wrap="square"/>
-                    <a:lstStyle/>
-                    <a:p>
-                      <a:pPr algn="ctr">
-                        <a:lnSpc>
-                          <a:spcPct val="100000"/>
-                        </a:lnSpc>
-                      </a:pPr>
-                      <a:r>
-                        <a:rPr sz="819" b="1">
-                          <a:solidFill>
-                            <a:srgbClr val="FFFFFF"/>
-                          </a:solidFill>
-                          <a:latin typeface="Microsoft YaHei"/>
-                          <a:ea typeface="Microsoft YaHei"/>
-                          <a:cs typeface="Microsoft YaHei"/>
-                        </a:rPr>
-                        <a:t>β 末值</a:t>
-                      </a:r>
-                    </a:p>
-                  </a:txBody>
-                  <a:tcPr marL="73152" marR="54864" marT="18288" marB="18288" anchor="ctr">
-                    <a:solidFill>
-                      <a:srgbClr val="0F1B2D"/>
-                    </a:solidFill>
-                  </a:tcPr>
-                </a:tc>
-              </a:tr>
-              <a:tr h="256032">
-                <a:tc>
-                  <a:txBody>
-                    <a:bodyPr wrap="square"/>
-                    <a:lstStyle/>
-                    <a:p>
-                      <a:pPr algn="l">
-                        <a:lnSpc>
-                          <a:spcPct val="100000"/>
-                        </a:lnSpc>
-                      </a:pPr>
-                      <a:r>
-                        <a:rPr sz="819" b="1">
-                          <a:solidFill>
-                            <a:srgbClr val="0F1B2D"/>
-                          </a:solidFill>
-                          <a:latin typeface="Microsoft YaHei"/>
-                          <a:ea typeface="Microsoft YaHei"/>
-                          <a:cs typeface="Microsoft YaHei"/>
-                        </a:rPr>
-                        <a:t>官方 β</a:t>
-                      </a:r>
-                    </a:p>
-                  </a:txBody>
-                  <a:tcPr marL="73152" marR="54864" marT="18288" marB="18288" anchor="ctr">
-                    <a:solidFill>
-                      <a:srgbClr val="FFFFFF"/>
-                    </a:solidFill>
-                  </a:tcPr>
-                </a:tc>
-                <a:tc>
-                  <a:txBody>
-                    <a:bodyPr wrap="square"/>
-                    <a:lstStyle/>
-                    <a:p>
-                      <a:pPr algn="ctr">
-                        <a:lnSpc>
-                          <a:spcPct val="100000"/>
-                        </a:lnSpc>
-                      </a:pPr>
-                      <a:r>
-                        <a:rPr sz="819" b="0">
-                          <a:solidFill>
-                            <a:srgbClr val="1B263B"/>
-                          </a:solidFill>
-                          <a:latin typeface="Microsoft YaHei"/>
-                          <a:ea typeface="Microsoft YaHei"/>
-                          <a:cs typeface="Microsoft YaHei"/>
-                        </a:rPr>
-                        <a:t>0.94</a:t>
-                      </a:r>
-                    </a:p>
-                  </a:txBody>
-                  <a:tcPr marL="73152" marR="54864" marT="18288" marB="18288" anchor="ctr">
-                    <a:solidFill>
-                      <a:srgbClr val="FFFFFF"/>
-                    </a:solidFill>
-                  </a:tcPr>
-                </a:tc>
-                <a:tc>
-                  <a:txBody>
-                    <a:bodyPr wrap="square"/>
-                    <a:lstStyle/>
-                    <a:p>
-                      <a:pPr algn="ctr">
-                        <a:lnSpc>
-                          <a:spcPct val="100000"/>
-                        </a:lnSpc>
-                      </a:pPr>
-                      <a:r>
-                        <a:rPr sz="819" b="0">
+                        <a:rPr sz="780" b="0">
                           <a:solidFill>
                             <a:srgbClr val="1B263B"/>
                           </a:solidFill>
@@ -5978,7 +6332,7 @@
                         </a:lnSpc>
                       </a:pPr>
                       <a:r>
-                        <a:rPr sz="819" b="0">
+                        <a:rPr sz="780" b="0">
                           <a:solidFill>
                             <a:srgbClr val="1B263B"/>
                           </a:solidFill>
@@ -5986,243 +6340,7 @@
                           <a:ea typeface="Microsoft YaHei"/>
                           <a:cs typeface="Microsoft YaHei"/>
                         </a:rPr>
-                        <a:t>12.9</a:t>
-                      </a:r>
-                    </a:p>
-                  </a:txBody>
-                  <a:tcPr marL="73152" marR="54864" marT="18288" marB="18288" anchor="ctr">
-                    <a:solidFill>
-                      <a:srgbClr val="FFFFFF"/>
-                    </a:solidFill>
-                  </a:tcPr>
-                </a:tc>
-              </a:tr>
-              <a:tr h="256032">
-                <a:tc>
-                  <a:txBody>
-                    <a:bodyPr wrap="square"/>
-                    <a:lstStyle/>
-                    <a:p>
-                      <a:pPr algn="l">
-                        <a:lnSpc>
-                          <a:spcPct val="100000"/>
-                        </a:lnSpc>
-                      </a:pPr>
-                      <a:r>
-                        <a:rPr sz="819" b="1">
-                          <a:solidFill>
-                            <a:srgbClr val="0F1B2D"/>
-                          </a:solidFill>
-                          <a:latin typeface="Microsoft YaHei"/>
-                          <a:ea typeface="Microsoft YaHei"/>
-                          <a:cs typeface="Microsoft YaHei"/>
-                        </a:rPr>
-                        <a:t>论文 Eq.(9) 符号</a:t>
-                      </a:r>
-                    </a:p>
-                  </a:txBody>
-                  <a:tcPr marL="73152" marR="54864" marT="18288" marB="18288" anchor="ctr">
-                    <a:solidFill>
-                      <a:srgbClr val="F5F7FB"/>
-                    </a:solidFill>
-                  </a:tcPr>
-                </a:tc>
-                <a:tc>
-                  <a:txBody>
-                    <a:bodyPr wrap="square"/>
-                    <a:lstStyle/>
-                    <a:p>
-                      <a:pPr algn="ctr">
-                        <a:lnSpc>
-                          <a:spcPct val="100000"/>
-                        </a:lnSpc>
-                      </a:pPr>
-                      <a:r>
-                        <a:rPr sz="819" b="0">
-                          <a:solidFill>
-                            <a:srgbClr val="1B263B"/>
-                          </a:solidFill>
-                          <a:latin typeface="Microsoft YaHei"/>
-                          <a:ea typeface="Microsoft YaHei"/>
-                          <a:cs typeface="Microsoft YaHei"/>
-                        </a:rPr>
-                        <a:t>0.96</a:t>
-                      </a:r>
-                    </a:p>
-                  </a:txBody>
-                  <a:tcPr marL="73152" marR="54864" marT="18288" marB="18288" anchor="ctr">
-                    <a:solidFill>
-                      <a:srgbClr val="F5F7FB"/>
-                    </a:solidFill>
-                  </a:tcPr>
-                </a:tc>
-                <a:tc>
-                  <a:txBody>
-                    <a:bodyPr wrap="square"/>
-                    <a:lstStyle/>
-                    <a:p>
-                      <a:pPr algn="ctr">
-                        <a:lnSpc>
-                          <a:spcPct val="100000"/>
-                        </a:lnSpc>
-                      </a:pPr>
-                      <a:r>
-                        <a:rPr sz="819" b="0">
-                          <a:solidFill>
-                            <a:srgbClr val="1B263B"/>
-                          </a:solidFill>
-                          <a:latin typeface="Microsoft YaHei"/>
-                          <a:ea typeface="Microsoft YaHei"/>
-                          <a:cs typeface="Microsoft YaHei"/>
-                        </a:rPr>
-                        <a:t>1.00</a:t>
-                      </a:r>
-                    </a:p>
-                  </a:txBody>
-                  <a:tcPr marL="73152" marR="54864" marT="18288" marB="18288" anchor="ctr">
-                    <a:solidFill>
-                      <a:srgbClr val="F5F7FB"/>
-                    </a:solidFill>
-                  </a:tcPr>
-                </a:tc>
-                <a:tc>
-                  <a:txBody>
-                    <a:bodyPr wrap="square"/>
-                    <a:lstStyle/>
-                    <a:p>
-                      <a:pPr algn="ctr">
-                        <a:lnSpc>
-                          <a:spcPct val="100000"/>
-                        </a:lnSpc>
-                      </a:pPr>
-                      <a:r>
-                        <a:rPr sz="819" b="0">
-                          <a:solidFill>
-                            <a:srgbClr val="1B263B"/>
-                          </a:solidFill>
-                          <a:latin typeface="Microsoft YaHei"/>
-                          <a:ea typeface="Microsoft YaHei"/>
-                          <a:cs typeface="Microsoft YaHei"/>
-                        </a:rPr>
-                        <a:t>7.1</a:t>
-                      </a:r>
-                    </a:p>
-                  </a:txBody>
-                  <a:tcPr marL="73152" marR="54864" marT="18288" marB="18288" anchor="ctr">
-                    <a:solidFill>
-                      <a:srgbClr val="F5F7FB"/>
-                    </a:solidFill>
-                  </a:tcPr>
-                </a:tc>
-              </a:tr>
-              <a:tr h="256032">
-                <a:tc>
-                  <a:txBody>
-                    <a:bodyPr wrap="square"/>
-                    <a:lstStyle/>
-                    <a:p>
-                      <a:pPr algn="l">
-                        <a:lnSpc>
-                          <a:spcPct val="100000"/>
-                        </a:lnSpc>
-                      </a:pPr>
-                      <a:r>
-                        <a:rPr sz="819" b="1">
-                          <a:solidFill>
-                            <a:srgbClr val="0F1B2D"/>
-                          </a:solidFill>
-                          <a:latin typeface="Microsoft YaHei"/>
-                          <a:ea typeface="Microsoft YaHei"/>
-                          <a:cs typeface="Microsoft YaHei"/>
-                        </a:rPr>
-                        <a:t>固定 β=10</a:t>
-                      </a:r>
-                    </a:p>
-                  </a:txBody>
-                  <a:tcPr marL="73152" marR="54864" marT="18288" marB="18288" anchor="ctr">
-                    <a:solidFill>
-                      <a:srgbClr val="FFFFFF"/>
-                    </a:solidFill>
-                  </a:tcPr>
-                </a:tc>
-                <a:tc>
-                  <a:txBody>
-                    <a:bodyPr wrap="square"/>
-                    <a:lstStyle/>
-                    <a:p>
-                      <a:pPr algn="ctr">
-                        <a:lnSpc>
-                          <a:spcPct val="100000"/>
-                        </a:lnSpc>
-                      </a:pPr>
-                      <a:r>
-                        <a:rPr sz="819" b="0">
-                          <a:solidFill>
-                            <a:srgbClr val="1B263B"/>
-                          </a:solidFill>
-                          <a:latin typeface="Microsoft YaHei"/>
-                          <a:ea typeface="Microsoft YaHei"/>
-                          <a:cs typeface="Microsoft YaHei"/>
-                        </a:rPr>
-                        <a:t>0.94</a:t>
-                      </a:r>
-                    </a:p>
-                  </a:txBody>
-                  <a:tcPr marL="73152" marR="54864" marT="18288" marB="18288" anchor="ctr">
-                    <a:solidFill>
-                      <a:srgbClr val="FFFFFF"/>
-                    </a:solidFill>
-                  </a:tcPr>
-                </a:tc>
-                <a:tc>
-                  <a:txBody>
-                    <a:bodyPr wrap="square"/>
-                    <a:lstStyle/>
-                    <a:p>
-                      <a:pPr algn="ctr">
-                        <a:lnSpc>
-                          <a:spcPct val="100000"/>
-                        </a:lnSpc>
-                      </a:pPr>
-                      <a:r>
-                        <a:rPr sz="819" b="0">
-                          <a:solidFill>
-                            <a:srgbClr val="1B263B"/>
-                          </a:solidFill>
-                          <a:latin typeface="Microsoft YaHei"/>
-                          <a:ea typeface="Microsoft YaHei"/>
-                          <a:cs typeface="Microsoft YaHei"/>
-                        </a:rPr>
-                        <a:t>1.00</a:t>
-                      </a:r>
-                    </a:p>
-                  </a:txBody>
-                  <a:tcPr marL="73152" marR="54864" marT="18288" marB="18288" anchor="ctr">
-                    <a:solidFill>
-                      <a:srgbClr val="FFFFFF"/>
-                    </a:solidFill>
-                  </a:tcPr>
-                </a:tc>
-                <a:tc>
-                  <a:txBody>
-                    <a:bodyPr wrap="square"/>
-                    <a:lstStyle/>
-                    <a:p>
-                      <a:pPr algn="ctr">
-                        <a:lnSpc>
-                          <a:spcPct val="100000"/>
-                        </a:lnSpc>
-                      </a:pPr>
-                      <a:r>
-                        <a:rPr sz="819" b="0">
-                          <a:solidFill>
-                            <a:srgbClr val="1B263B"/>
-                          </a:solidFill>
-                          <a:latin typeface="Microsoft YaHei"/>
-                          <a:ea typeface="Microsoft YaHei"/>
-                          <a:cs typeface="Microsoft YaHei"/>
-                        </a:rPr>
-                        <a:t>10.0</a:t>
+                        <a:t>略优</a:t>
                       </a:r>
                     </a:p>
                   </a:txBody>
@@ -6237,9 +6355,96 @@
           </a:graphicData>
         </a:graphic>
       </p:graphicFrame>
+      <p:sp>
+        <p:nvSpPr>
+          <p:cNvPr id="14" name="TextBox 13"/>
+          <p:cNvSpPr txBox="1"/>
+          <p:nvPr/>
+        </p:nvSpPr>
+        <p:spPr>
+          <a:xfrm>
+            <a:off x="6720840" y="2788920"/>
+            <a:ext cx="4572000" cy="685800"/>
+          </a:xfrm>
+          <a:prstGeom prst="rect">
+            <a:avLst/>
+          </a:prstGeom>
+          <a:noFill/>
+        </p:spPr>
+        <p:txBody>
+          <a:bodyPr wrap="square" lIns="0" rIns="0" tIns="0" bIns="0">
+            <a:spAutoFit/>
+          </a:bodyPr>
+          <a:lstStyle/>
+          <a:p>
+            <a:pPr>
+              <a:lnSpc>
+                <a:spcPct val="122000"/>
+              </a:lnSpc>
+              <a:spcAft>
+                <a:spcPts val="100"/>
+              </a:spcAft>
+            </a:pPr>
+            <a:r>
+              <a:rPr sz="740" b="0">
+                <a:solidFill>
+                  <a:srgbClr val="C97F1C"/>
+                </a:solidFill>
+                <a:latin typeface="Microsoft YaHei"/>
+                <a:ea typeface="Microsoft YaHei"/>
+                <a:cs typeface="Microsoft YaHei"/>
+              </a:rPr>
+              <a:t>• </a:t>
+            </a:r>
+            <a:r>
+              <a:rPr sz="740" b="0">
+                <a:solidFill>
+                  <a:srgbClr val="1B263B"/>
+                </a:solidFill>
+                <a:latin typeface="Microsoft YaHei"/>
+                <a:ea typeface="Microsoft YaHei"/>
+                <a:cs typeface="Microsoft YaHei"/>
+              </a:rPr>
+              <a:t>官方 seed1 0.96；Eq.(7) seed1 0.12（崩溃可重复）</a:t>
+            </a:r>
+          </a:p>
+          <a:p>
+            <a:pPr>
+              <a:lnSpc>
+                <a:spcPct val="122000"/>
+              </a:lnSpc>
+              <a:spcAft>
+                <a:spcPts val="100"/>
+              </a:spcAft>
+            </a:pPr>
+            <a:r>
+              <a:rPr sz="740" b="0">
+                <a:solidFill>
+                  <a:srgbClr val="C97F1C"/>
+                </a:solidFill>
+                <a:latin typeface="Microsoft YaHei"/>
+                <a:ea typeface="Microsoft YaHei"/>
+                <a:cs typeface="Microsoft YaHei"/>
+              </a:rPr>
+              <a:t>• </a:t>
+            </a:r>
+            <a:r>
+              <a:rPr sz="740" b="0">
+                <a:solidFill>
+                  <a:srgbClr val="1B263B"/>
+                </a:solidFill>
+                <a:latin typeface="Microsoft YaHei"/>
+                <a:ea typeface="Microsoft YaHei"/>
+                <a:cs typeface="Microsoft YaHei"/>
+              </a:rPr>
+              <a:t>humanoidmaze Eq.(7) 0.00（跨任务崩溃）；β 0.94 vs 0.96</a:t>
+            </a:r>
+          </a:p>
+        </p:txBody>
+      </p:sp>
       <p:pic>
         <p:nvPicPr>
-          <p:cNvPr id="14" name="Picture 13" descr="fig_ablation_schedule_success.png"/>
+          <p:cNvPr id="15" name="Picture 14" descr="fig_ablation_schedule_scale.png"/>
           <p:cNvPicPr>
             <a:picLocks noChangeAspect="1"/>
           </p:cNvPicPr>
@@ -6253,8 +6458,8 @@
         </p:blipFill>
         <p:spPr>
           <a:xfrm>
-            <a:off x="1313905" y="3364992"/>
-            <a:ext cx="4550228" cy="1737360"/>
+            <a:off x="1326968" y="3611880"/>
+            <a:ext cx="4386942" cy="1417320"/>
           </a:xfrm>
           <a:prstGeom prst="rect">
             <a:avLst/>
@@ -6263,14 +6468,14 @@
       </p:pic>
       <p:sp>
         <p:nvSpPr>
-          <p:cNvPr id="15" name="Rounded Rectangle 14"/>
+          <p:cNvPr id="16" name="Rounded Rectangle 15"/>
           <p:cNvSpPr/>
           <p:nvPr/>
         </p:nvSpPr>
         <p:spPr>
           <a:xfrm>
-            <a:off x="6720840" y="3364992"/>
-            <a:ext cx="4782312" cy="1737360"/>
+            <a:off x="6492240" y="3611880"/>
+            <a:ext cx="5010912" cy="1417320"/>
           </a:xfrm>
           <a:prstGeom prst="roundRect">
             <a:avLst>
@@ -6311,14 +6516,14 @@
       </p:sp>
       <p:sp>
         <p:nvSpPr>
-          <p:cNvPr id="16" name="TextBox 15"/>
+          <p:cNvPr id="17" name="TextBox 16"/>
           <p:cNvSpPr txBox="1"/>
           <p:nvPr/>
         </p:nvSpPr>
         <p:spPr>
           <a:xfrm>
-            <a:off x="6903720" y="3447288"/>
-            <a:ext cx="4389120" cy="256032"/>
+            <a:off x="6675120" y="3685032"/>
+            <a:ext cx="4617720" cy="237744"/>
           </a:xfrm>
           <a:prstGeom prst="rect">
             <a:avLst/>
@@ -6337,7 +6542,7 @@
               </a:lnSpc>
             </a:pPr>
             <a:r>
-              <a:rPr sz="1080" b="1">
+              <a:rPr sz="1050" b="1">
                 <a:solidFill>
                   <a:srgbClr val="C04B4B"/>
                 </a:solidFill>
@@ -6352,14 +6557,14 @@
       </p:sp>
       <p:sp>
         <p:nvSpPr>
-          <p:cNvPr id="17" name="TextBox 16"/>
+          <p:cNvPr id="18" name="TextBox 17"/>
           <p:cNvSpPr txBox="1"/>
           <p:nvPr/>
         </p:nvSpPr>
         <p:spPr>
           <a:xfrm>
-            <a:off x="6903720" y="3721608"/>
-            <a:ext cx="4389120" cy="1371600"/>
+            <a:off x="6675120" y="3931920"/>
+            <a:ext cx="4617720" cy="1051560"/>
           </a:xfrm>
           <a:prstGeom prst="rect">
             <a:avLst/>
@@ -6377,11 +6582,11 @@
                 <a:spcPct val="122000"/>
               </a:lnSpc>
               <a:spcAft>
-                <a:spcPts val="200"/>
+                <a:spcPts val="100"/>
               </a:spcAft>
             </a:pPr>
             <a:r>
-              <a:rPr sz="819" b="0">
+              <a:rPr sz="760" b="0">
                 <a:solidFill>
                   <a:srgbClr val="C04B4B"/>
                 </a:solidFill>
@@ -6392,7 +6597,7 @@
               <a:t>• </a:t>
             </a:r>
             <a:r>
-              <a:rPr sz="819" b="0">
+              <a:rPr sz="760" b="0">
                 <a:solidFill>
                   <a:srgbClr val="1B263B"/>
                 </a:solidFill>
@@ -6400,7 +6605,7 @@
                 <a:ea typeface="Microsoft YaHei"/>
                 <a:cs typeface="Microsoft YaHei"/>
               </a:rPr>
-              <a:t>论文 Eq.(7) 字面实现：在线期崩溃（1M 时 0.62 → 1.1M 后 0.02–0）</a:t>
+              <a:t>未缩放：峰值噪声 0.229 = 官方 340×，BC loss 0.42，在线崩溃</a:t>
             </a:r>
           </a:p>
           <a:p>
@@ -6409,11 +6614,11 @@
                 <a:spcPct val="122000"/>
               </a:lnSpc>
               <a:spcAft>
-                <a:spcPts val="200"/>
+                <a:spcPts val="100"/>
               </a:spcAft>
             </a:pPr>
             <a:r>
-              <a:rPr sz="819" b="0">
+              <a:rPr sz="760" b="0">
                 <a:solidFill>
                   <a:srgbClr val="C04B4B"/>
                 </a:solidFill>
@@ -6424,7 +6629,7 @@
               <a:t>• </a:t>
             </a:r>
             <a:r>
-              <a:rPr sz="819" b="0">
+              <a:rPr sz="760" b="0">
                 <a:solidFill>
                   <a:srgbClr val="1B263B"/>
                 </a:solidFill>
@@ -6432,7 +6637,7 @@
                 <a:ea typeface="Microsoft YaHei"/>
                 <a:cs typeface="Microsoft YaHei"/>
               </a:rPr>
-              <a:t>BC flow loss 0.42 vs 官方 0.29 / 无噪声 0.26 → 中段噪声（约 340×）破坏拟合</a:t>
+              <a:t>归一化到峰值 0.1 → 0.94；方差读法 → 1.00：形状可用、缺归一化</a:t>
             </a:r>
           </a:p>
           <a:p>
@@ -6441,11 +6646,11 @@
                 <a:spcPct val="122000"/>
               </a:lnSpc>
               <a:spcAft>
-                <a:spcPts val="200"/>
+                <a:spcPts val="100"/>
               </a:spcAft>
             </a:pPr>
             <a:r>
-              <a:rPr sz="819" b="0">
+              <a:rPr sz="760" b="0">
                 <a:solidFill>
                   <a:srgbClr val="C04B4B"/>
                 </a:solidFill>
@@ -6456,7 +6661,7 @@
               <a:t>• </a:t>
             </a:r>
             <a:r>
-              <a:rPr sz="819" b="0">
+              <a:rPr sz="760" b="0">
                 <a:solidFill>
                   <a:srgbClr val="1B263B"/>
                 </a:solidFill>
@@ -6464,53 +6669,21 @@
                 <a:ea typeface="Microsoft YaHei"/>
                 <a:cs typeface="Microsoft YaHei"/>
               </a:rPr>
-              <a:t>官方指数 schedule 最优；无噪声、η=0.3 均 0.96 → 噪声不是越强越好</a:t>
-            </a:r>
-          </a:p>
-          <a:p>
-            <a:pPr>
-              <a:lnSpc>
-                <a:spcPct val="122000"/>
-              </a:lnSpc>
-              <a:spcAft>
-                <a:spcPts val="200"/>
-              </a:spcAft>
-            </a:pPr>
-            <a:r>
-              <a:rPr sz="819" b="0">
-                <a:solidFill>
-                  <a:srgbClr val="C04B4B"/>
-                </a:solidFill>
-                <a:latin typeface="Microsoft YaHei"/>
-                <a:ea typeface="Microsoft YaHei"/>
-                <a:cs typeface="Microsoft YaHei"/>
-              </a:rPr>
-              <a:t>• </a:t>
-            </a:r>
-            <a:r>
-              <a:rPr sz="819" b="0">
-                <a:solidFill>
-                  <a:srgbClr val="1B263B"/>
-                </a:solidFill>
-                <a:latin typeface="Microsoft YaHei"/>
-                <a:ea typeface="Microsoft YaHei"/>
-                <a:cs typeface="Microsoft YaHei"/>
-              </a:rPr>
-              <a:t>β 符号方向影响很小（0.94 vs 0.96）；固定 β 略低</a:t>
-            </a:r>
-          </a:p>
-        </p:txBody>
-      </p:sp>
-      <p:sp>
-        <p:nvSpPr>
-          <p:cNvPr id="18" name="TextBox 17"/>
+              <a:t>崩溃复现：seed1 0.12、humanoid 0.00；K 越多略好（0.90/0.94/0.96）</a:t>
+            </a:r>
+          </a:p>
+        </p:txBody>
+      </p:sp>
+      <p:sp>
+        <p:nvSpPr>
+          <p:cNvPr id="19" name="TextBox 18"/>
           <p:cNvSpPr txBox="1"/>
           <p:nvPr/>
         </p:nvSpPr>
         <p:spPr>
           <a:xfrm>
-            <a:off x="685800" y="5230368"/>
-            <a:ext cx="10817352" cy="822960"/>
+            <a:off x="685800" y="5193792"/>
+            <a:ext cx="10817352" cy="1005840"/>
           </a:xfrm>
           <a:prstGeom prst="rect">
             <a:avLst/>
@@ -6529,7 +6702,7 @@
               </a:lnSpc>
             </a:pPr>
             <a:r>
-              <a:rPr sz="1019" b="0">
+              <a:rPr sz="960" b="0">
                 <a:solidFill>
                   <a:srgbClr val="1B263B"/>
                 </a:solidFill>
@@ -6537,14 +6710,14 @@
                 <a:ea typeface="Microsoft YaHei"/>
                 <a:cs typeface="Microsoft YaHei"/>
               </a:rPr>
-              <a:t>结论：论文公式与实现不一致不仅是文档问题——按 Eq.(7) 实现会破坏训练（0.04 vs 1.00）；以实现为准的复现策略成立，同时说明论文的公式逻辑需要修正。单 seed，但效应量级差异显著。</a:t>
-            </a:r>
-          </a:p>
-        </p:txBody>
-      </p:sp>
-      <p:sp>
-        <p:nvSpPr>
-          <p:cNvPr id="19" name="Rectangle 18"/>
+              <a:t>结论：论文 Eq.(7) 的失败是"幅度/归一化"问题，不是"形状"问题——归一化后与官方实现同量级（0.94–1.00）；但按论文给定 η=0.1 字面实现会崩溃（0.04/0.12/0.00），说明公式可作设计依据、实现必须校正幅度。</a:t>
+            </a:r>
+          </a:p>
+        </p:txBody>
+      </p:sp>
+      <p:sp>
+        <p:nvSpPr>
+          <p:cNvPr id="20" name="Rectangle 19"/>
           <p:cNvSpPr/>
           <p:nvPr/>
         </p:nvSpPr>
@@ -6588,7 +6761,7 @@
       </p:sp>
       <p:sp>
         <p:nvSpPr>
-          <p:cNvPr id="20" name="TextBox 19"/>
+          <p:cNvPr id="21" name="TextBox 20"/>
           <p:cNvSpPr txBox="1"/>
           <p:nvPr/>
         </p:nvSpPr>
@@ -6629,7 +6802,7 @@
       </p:sp>
       <p:sp>
         <p:nvSpPr>
-          <p:cNvPr id="21" name="TextBox 20"/>
+          <p:cNvPr id="22" name="TextBox 21"/>
           <p:cNvSpPr txBox="1"/>
           <p:nvPr/>
         </p:nvSpPr>
@@ -7487,7 +7660,7 @@
                           <a:ea typeface="Microsoft YaHei"/>
                           <a:cs typeface="Microsoft YaHei"/>
                         </a:rPr>
-                        <a:t>未做</a:t>
+                        <a:t>已补</a:t>
                       </a:r>
                     </a:p>
                   </a:txBody>
@@ -7530,7 +7703,7 @@
               </a:lnSpc>
             </a:pPr>
             <a:r>
-              <a:rPr sz="1000" b="1">
+              <a:rPr sz="940" b="1">
                 <a:solidFill>
                   <a:srgbClr val="C97F1C"/>
                 </a:solidFill>
@@ -7538,7 +7711,7 @@
                 <a:ea typeface="Microsoft YaHei"/>
                 <a:cs typeface="Microsoft YaHei"/>
               </a:rPr>
-              <a:t>合计完成：3/45 ≈ 7%（单 seed）</a:t>
+              <a:t>合计完成：3/45 ≈ 7%；主实验单 seed，公式/机制消融已补</a:t>
             </a:r>
           </a:p>
         </p:txBody>
@@ -7908,7 +8081,7 @@
                 <a:ea typeface="Microsoft YaHei"/>
                 <a:cs typeface="Microsoft YaHei"/>
               </a:rPr>
-              <a:t>这些是"论文描述与实现不一致"或"实验记录缺陷"，不影响主结果的成立（我们以代码为准复现）；但说明：① 若要严格对齐论文公式，需要做 schedule/β 的消融；② 单 seed + 3/45 覆盖，只能下"方法有效、与论文同量级"的结论，不能下"完整复现论文"的结论。</a:t>
+              <a:t>这些是"论文描述与实现不一致"或"实验记录缺陷"，不影响主结果的成立（我们以代码为准复现）；已补消融：公式幅度/形状、seed=1、humanoid 跨任务、Q-guided K、beta 变体；仍只能下"方法有效、与论文同量级"的结论，不能下"完整复现论文"的结论（覆盖 3/45，无 D4RL）。</a:t>
             </a:r>
           </a:p>
         </p:txBody>
@@ -8567,7 +8740,7 @@
                 <a:ea typeface="Microsoft YaHei"/>
                 <a:cs typeface="Microsoft YaHei"/>
               </a:rPr>
-              <a:t>训练损失与 Q 值收敛正常；蒸馏保真（ED≈0.006）；公式消融显示论文 Eq.(7) 字面实现会崩溃（0.04），官方实现最优（1.00），β 符号影响很小（0.94 vs 0.96）。</a:t>
+              <a:t>训练损失与 Q 值收敛正常；蒸馏保真（ED≈0.006）；Eq.(7) 未缩放会崩溃（0.04/0.12/0.00），但峰值归一化后恢复（0.94–1.00）→ 问题在幅度而非形状；K=1/4/10 为 0.90/0.94/0.96。</a:t>
             </a:r>
           </a:p>
         </p:txBody>
@@ -8697,7 +8870,7 @@
                 <a:ea typeface="Microsoft YaHei"/>
                 <a:cs typeface="Microsoft YaHei"/>
               </a:rPr>
-              <a:t>3/45 任务、单 seed、无 D4RL；公式消融已补做（A/B 组），Q-guided K 与多 seed 未做；主结果仍只能下"方法有效、与论文同量级"的结论。</a:t>
+              <a:t>3/45 任务、D4RL 未覆盖、部分任务单 seed；公式幅度/形状、seed=1、跨任务、K 已补做；仍只能下"方法有效、与论文同量级"的结论。</a:t>
             </a:r>
           </a:p>
         </p:txBody>

</xml_diff>